<commit_message>
Add SIV-AI FastAPI backend deployment
</commit_message>
<xml_diff>
--- a/SIV-AI_Solution.pptx
+++ b/SIV-AI_Solution.pptx
@@ -5,7 +5,7 @@
     <p:sldMasterId id="2147483648" r:id="rId1"/>
   </p:sldMasterIdLst>
   <p:notesMasterIdLst>
-    <p:notesMasterId r:id="rId15"/>
+    <p:notesMasterId r:id="rId16"/>
   </p:notesMasterIdLst>
   <p:sldIdLst>
     <p:sldId id="256" r:id="rId2"/>
@@ -20,7 +20,8 @@
     <p:sldId id="264" r:id="rId11"/>
     <p:sldId id="265" r:id="rId12"/>
     <p:sldId id="266" r:id="rId13"/>
-    <p:sldId id="267" r:id="rId14"/>
+    <p:sldId id="269" r:id="rId14"/>
+    <p:sldId id="267" r:id="rId15"/>
   </p:sldIdLst>
   <p:sldSz cx="12188825" cy="6858000"/>
   <p:notesSz cx="6858000" cy="12188825"/>
@@ -127,9 +128,307 @@
 <file path=ppt/revisionInfo.xml><?xml version="1.0" encoding="utf-8"?>
 <p1510:revInfo xmlns:a="http://schemas.openxmlformats.org/drawingml/2006/main" xmlns:r="http://schemas.openxmlformats.org/officeDocument/2006/relationships" xmlns:p1510="http://schemas.microsoft.com/office/powerpoint/2015/10/main">
   <p1510:revLst>
-    <p1510:client id="{EC12282C-C34D-4E81-B78B-4ABFFF103DA4}" v="3" dt="2026-08-15T11:20:56.515"/>
+    <p1510:client id="{42550961-0400-4664-A637-AEF1F380961D}" v="10" dt="2026-08-16T09:50:52.677"/>
   </p1510:revLst>
 </p1510:revInfo>
+</file>
+
+<file path=ppt/changesInfos/changesInfo1.xml><?xml version="1.0" encoding="utf-8"?>
+<pc:chgInfo xmlns:a="http://schemas.openxmlformats.org/drawingml/2006/main" xmlns:r="http://schemas.openxmlformats.org/officeDocument/2006/relationships" xmlns:ac="http://schemas.microsoft.com/office/drawing/2013/main/command" xmlns:pc="http://schemas.microsoft.com/office/powerpoint/2013/main/command">
+  <pc:docChgLst>
+    <pc:chgData name="LOGESH S" userId="536108a5c8606ce5" providerId="LiveId" clId="{BDE1E0A8-B346-494B-B5C1-64FF4A45B7D3}"/>
+    <pc:docChg chg="undo custSel addSld delSld modSld">
+      <pc:chgData name="LOGESH S" userId="536108a5c8606ce5" providerId="LiveId" clId="{BDE1E0A8-B346-494B-B5C1-64FF4A45B7D3}" dt="2026-08-16T09:51:14.735" v="170" actId="255"/>
+      <pc:docMkLst>
+        <pc:docMk/>
+      </pc:docMkLst>
+      <pc:sldChg chg="addSp modSp mod">
+        <pc:chgData name="LOGESH S" userId="536108a5c8606ce5" providerId="LiveId" clId="{BDE1E0A8-B346-494B-B5C1-64FF4A45B7D3}" dt="2026-08-16T09:42:39.533" v="34" actId="207"/>
+        <pc:sldMkLst>
+          <pc:docMk/>
+          <pc:sldMk cId="0" sldId="256"/>
+        </pc:sldMkLst>
+        <pc:spChg chg="mod">
+          <ac:chgData name="LOGESH S" userId="536108a5c8606ce5" providerId="LiveId" clId="{BDE1E0A8-B346-494B-B5C1-64FF4A45B7D3}" dt="2026-08-16T09:41:29.418" v="14" actId="21"/>
+          <ac:spMkLst>
+            <pc:docMk/>
+            <pc:sldMk cId="0" sldId="256"/>
+            <ac:spMk id="8" creationId="{00000000-0000-0000-0000-000000000000}"/>
+          </ac:spMkLst>
+        </pc:spChg>
+        <pc:spChg chg="mod">
+          <ac:chgData name="LOGESH S" userId="536108a5c8606ce5" providerId="LiveId" clId="{BDE1E0A8-B346-494B-B5C1-64FF4A45B7D3}" dt="2026-08-16T09:42:24.682" v="32" actId="1076"/>
+          <ac:spMkLst>
+            <pc:docMk/>
+            <pc:sldMk cId="0" sldId="256"/>
+            <ac:spMk id="10" creationId="{00000000-0000-0000-0000-000000000000}"/>
+          </ac:spMkLst>
+        </pc:spChg>
+        <pc:spChg chg="mod">
+          <ac:chgData name="LOGESH S" userId="536108a5c8606ce5" providerId="LiveId" clId="{BDE1E0A8-B346-494B-B5C1-64FF4A45B7D3}" dt="2026-08-16T09:41:39.006" v="17" actId="20577"/>
+          <ac:spMkLst>
+            <pc:docMk/>
+            <pc:sldMk cId="0" sldId="256"/>
+            <ac:spMk id="16" creationId="{00000000-0000-0000-0000-000000000000}"/>
+          </ac:spMkLst>
+        </pc:spChg>
+        <pc:spChg chg="add mod">
+          <ac:chgData name="LOGESH S" userId="536108a5c8606ce5" providerId="LiveId" clId="{BDE1E0A8-B346-494B-B5C1-64FF4A45B7D3}" dt="2026-08-16T09:42:01.842" v="28" actId="20577"/>
+          <ac:spMkLst>
+            <pc:docMk/>
+            <pc:sldMk cId="0" sldId="256"/>
+            <ac:spMk id="20" creationId="{7B4C68CF-6CF6-E2E9-E1DB-C76C236AC2BB}"/>
+          </ac:spMkLst>
+        </pc:spChg>
+        <pc:spChg chg="add mod">
+          <ac:chgData name="LOGESH S" userId="536108a5c8606ce5" providerId="LiveId" clId="{BDE1E0A8-B346-494B-B5C1-64FF4A45B7D3}" dt="2026-08-16T09:42:39.533" v="34" actId="207"/>
+          <ac:spMkLst>
+            <pc:docMk/>
+            <pc:sldMk cId="0" sldId="256"/>
+            <ac:spMk id="21" creationId="{CF94BF33-396D-AA49-6010-D07441CEE11D}"/>
+          </ac:spMkLst>
+        </pc:spChg>
+      </pc:sldChg>
+      <pc:sldChg chg="modSp mod">
+        <pc:chgData name="LOGESH S" userId="536108a5c8606ce5" providerId="LiveId" clId="{BDE1E0A8-B346-494B-B5C1-64FF4A45B7D3}" dt="2026-08-16T09:43:25.262" v="68" actId="14100"/>
+        <pc:sldMkLst>
+          <pc:docMk/>
+          <pc:sldMk cId="0" sldId="267"/>
+        </pc:sldMkLst>
+        <pc:spChg chg="mod">
+          <ac:chgData name="LOGESH S" userId="536108a5c8606ce5" providerId="LiveId" clId="{BDE1E0A8-B346-494B-B5C1-64FF4A45B7D3}" dt="2026-08-16T09:43:09.775" v="47" actId="14100"/>
+          <ac:spMkLst>
+            <pc:docMk/>
+            <pc:sldMk cId="0" sldId="267"/>
+            <ac:spMk id="46" creationId="{00000000-0000-0000-0000-000000000000}"/>
+          </ac:spMkLst>
+        </pc:spChg>
+        <pc:spChg chg="mod">
+          <ac:chgData name="LOGESH S" userId="536108a5c8606ce5" providerId="LiveId" clId="{BDE1E0A8-B346-494B-B5C1-64FF4A45B7D3}" dt="2026-08-16T09:43:17.184" v="66" actId="20577"/>
+          <ac:spMkLst>
+            <pc:docMk/>
+            <pc:sldMk cId="0" sldId="267"/>
+            <ac:spMk id="47" creationId="{00000000-0000-0000-0000-000000000000}"/>
+          </ac:spMkLst>
+        </pc:spChg>
+        <pc:spChg chg="mod">
+          <ac:chgData name="LOGESH S" userId="536108a5c8606ce5" providerId="LiveId" clId="{BDE1E0A8-B346-494B-B5C1-64FF4A45B7D3}" dt="2026-08-16T09:43:25.262" v="68" actId="14100"/>
+          <ac:spMkLst>
+            <pc:docMk/>
+            <pc:sldMk cId="0" sldId="267"/>
+            <ac:spMk id="48" creationId="{00000000-0000-0000-0000-000000000000}"/>
+          </ac:spMkLst>
+        </pc:spChg>
+      </pc:sldChg>
+      <pc:sldChg chg="addSp delSp modSp add mod">
+        <pc:chgData name="LOGESH S" userId="536108a5c8606ce5" providerId="LiveId" clId="{BDE1E0A8-B346-494B-B5C1-64FF4A45B7D3}" dt="2026-08-16T09:51:14.735" v="170" actId="255"/>
+        <pc:sldMkLst>
+          <pc:docMk/>
+          <pc:sldMk cId="1753150815" sldId="269"/>
+        </pc:sldMkLst>
+        <pc:spChg chg="add mod">
+          <ac:chgData name="LOGESH S" userId="536108a5c8606ce5" providerId="LiveId" clId="{BDE1E0A8-B346-494B-B5C1-64FF4A45B7D3}" dt="2026-08-16T09:50:06.240" v="142" actId="1076"/>
+          <ac:spMkLst>
+            <pc:docMk/>
+            <pc:sldMk cId="1753150815" sldId="269"/>
+            <ac:spMk id="36" creationId="{E244C643-6FF7-0C5E-62CF-45E93C464D5E}"/>
+          </ac:spMkLst>
+        </pc:spChg>
+        <pc:spChg chg="add mod">
+          <ac:chgData name="LOGESH S" userId="536108a5c8606ce5" providerId="LiveId" clId="{BDE1E0A8-B346-494B-B5C1-64FF4A45B7D3}" dt="2026-08-16T09:49:54.193" v="139" actId="1076"/>
+          <ac:spMkLst>
+            <pc:docMk/>
+            <pc:sldMk cId="1753150815" sldId="269"/>
+            <ac:spMk id="38" creationId="{1BBA7258-D560-77CF-A4EB-13F794E33A56}"/>
+          </ac:spMkLst>
+        </pc:spChg>
+        <pc:spChg chg="add mod">
+          <ac:chgData name="LOGESH S" userId="536108a5c8606ce5" providerId="LiveId" clId="{BDE1E0A8-B346-494B-B5C1-64FF4A45B7D3}" dt="2026-08-16T09:49:37.963" v="134" actId="20577"/>
+          <ac:spMkLst>
+            <pc:docMk/>
+            <pc:sldMk cId="1753150815" sldId="269"/>
+            <ac:spMk id="40" creationId="{EE2C66D2-FFEF-0FBE-DE1A-638156011E25}"/>
+          </ac:spMkLst>
+        </pc:spChg>
+        <pc:spChg chg="add mod">
+          <ac:chgData name="LOGESH S" userId="536108a5c8606ce5" providerId="LiveId" clId="{BDE1E0A8-B346-494B-B5C1-64FF4A45B7D3}" dt="2026-08-16T09:50:15.421" v="144" actId="1076"/>
+          <ac:spMkLst>
+            <pc:docMk/>
+            <pc:sldMk cId="1753150815" sldId="269"/>
+            <ac:spMk id="42" creationId="{465CF17B-5C70-712D-2318-6A52535928B3}"/>
+          </ac:spMkLst>
+        </pc:spChg>
+        <pc:spChg chg="add mod">
+          <ac:chgData name="LOGESH S" userId="536108a5c8606ce5" providerId="LiveId" clId="{BDE1E0A8-B346-494B-B5C1-64FF4A45B7D3}" dt="2026-08-16T09:49:45.755" v="137" actId="20577"/>
+          <ac:spMkLst>
+            <pc:docMk/>
+            <pc:sldMk cId="1753150815" sldId="269"/>
+            <ac:spMk id="44" creationId="{E95881CD-6BB4-2AEE-C1B7-B2911CB7E23D}"/>
+          </ac:spMkLst>
+        </pc:spChg>
+        <pc:spChg chg="add mod">
+          <ac:chgData name="LOGESH S" userId="536108a5c8606ce5" providerId="LiveId" clId="{BDE1E0A8-B346-494B-B5C1-64FF4A45B7D3}" dt="2026-08-16T09:50:30.371" v="148" actId="1076"/>
+          <ac:spMkLst>
+            <pc:docMk/>
+            <pc:sldMk cId="1753150815" sldId="269"/>
+            <ac:spMk id="46" creationId="{C5A47210-C323-82F5-AA7E-8A28FB15728D}"/>
+          </ac:spMkLst>
+        </pc:spChg>
+        <pc:spChg chg="add mod">
+          <ac:chgData name="LOGESH S" userId="536108a5c8606ce5" providerId="LiveId" clId="{BDE1E0A8-B346-494B-B5C1-64FF4A45B7D3}" dt="2026-08-16T09:51:14.735" v="170" actId="255"/>
+          <ac:spMkLst>
+            <pc:docMk/>
+            <pc:sldMk cId="1753150815" sldId="269"/>
+            <ac:spMk id="47" creationId="{C5631F0B-0319-2B3F-226F-3DA1B4C172FB}"/>
+          </ac:spMkLst>
+        </pc:spChg>
+        <pc:picChg chg="add del mod">
+          <ac:chgData name="LOGESH S" userId="536108a5c8606ce5" providerId="LiveId" clId="{BDE1E0A8-B346-494B-B5C1-64FF4A45B7D3}" dt="2026-08-16T09:44:34.434" v="73" actId="478"/>
+          <ac:picMkLst>
+            <pc:docMk/>
+            <pc:sldMk cId="1753150815" sldId="269"/>
+            <ac:picMk id="3" creationId="{AA08C4B8-040A-E8DA-A624-98A29BDB988B}"/>
+          </ac:picMkLst>
+        </pc:picChg>
+        <pc:picChg chg="add del mod">
+          <ac:chgData name="LOGESH S" userId="536108a5c8606ce5" providerId="LiveId" clId="{BDE1E0A8-B346-494B-B5C1-64FF4A45B7D3}" dt="2026-08-16T09:44:34.434" v="73" actId="478"/>
+          <ac:picMkLst>
+            <pc:docMk/>
+            <pc:sldMk cId="1753150815" sldId="269"/>
+            <ac:picMk id="5" creationId="{BD01D34E-0D92-6442-5880-75E153A285A3}"/>
+          </ac:picMkLst>
+        </pc:picChg>
+        <pc:picChg chg="add del mod">
+          <ac:chgData name="LOGESH S" userId="536108a5c8606ce5" providerId="LiveId" clId="{BDE1E0A8-B346-494B-B5C1-64FF4A45B7D3}" dt="2026-08-16T09:44:34.434" v="73" actId="478"/>
+          <ac:picMkLst>
+            <pc:docMk/>
+            <pc:sldMk cId="1753150815" sldId="269"/>
+            <ac:picMk id="7" creationId="{12AB7C8A-DD50-C304-EBC0-5BD00F19E0E2}"/>
+          </ac:picMkLst>
+        </pc:picChg>
+        <pc:picChg chg="add del mod">
+          <ac:chgData name="LOGESH S" userId="536108a5c8606ce5" providerId="LiveId" clId="{BDE1E0A8-B346-494B-B5C1-64FF4A45B7D3}" dt="2026-08-16T09:44:34.434" v="73" actId="478"/>
+          <ac:picMkLst>
+            <pc:docMk/>
+            <pc:sldMk cId="1753150815" sldId="269"/>
+            <ac:picMk id="9" creationId="{7BA87C0A-74FA-6591-7284-DF77BF4F97EE}"/>
+          </ac:picMkLst>
+        </pc:picChg>
+        <pc:picChg chg="add del mod">
+          <ac:chgData name="LOGESH S" userId="536108a5c8606ce5" providerId="LiveId" clId="{BDE1E0A8-B346-494B-B5C1-64FF4A45B7D3}" dt="2026-08-16T09:44:34.434" v="73" actId="478"/>
+          <ac:picMkLst>
+            <pc:docMk/>
+            <pc:sldMk cId="1753150815" sldId="269"/>
+            <ac:picMk id="11" creationId="{ADFC37D8-5940-CD87-963E-4A11486E5083}"/>
+          </ac:picMkLst>
+        </pc:picChg>
+        <pc:picChg chg="add del mod">
+          <ac:chgData name="LOGESH S" userId="536108a5c8606ce5" providerId="LiveId" clId="{BDE1E0A8-B346-494B-B5C1-64FF4A45B7D3}" dt="2026-08-16T09:44:34.434" v="73" actId="478"/>
+          <ac:picMkLst>
+            <pc:docMk/>
+            <pc:sldMk cId="1753150815" sldId="269"/>
+            <ac:picMk id="13" creationId="{4F61195E-DD1D-C10E-5518-A50391B56360}"/>
+          </ac:picMkLst>
+        </pc:picChg>
+        <pc:picChg chg="add del mod">
+          <ac:chgData name="LOGESH S" userId="536108a5c8606ce5" providerId="LiveId" clId="{BDE1E0A8-B346-494B-B5C1-64FF4A45B7D3}" dt="2026-08-16T09:44:34.434" v="73" actId="478"/>
+          <ac:picMkLst>
+            <pc:docMk/>
+            <pc:sldMk cId="1753150815" sldId="269"/>
+            <ac:picMk id="15" creationId="{AD2C36AE-27C3-4C42-BEE0-DEE8EDD46E08}"/>
+          </ac:picMkLst>
+        </pc:picChg>
+        <pc:picChg chg="add del mod">
+          <ac:chgData name="LOGESH S" userId="536108a5c8606ce5" providerId="LiveId" clId="{BDE1E0A8-B346-494B-B5C1-64FF4A45B7D3}" dt="2026-08-16T09:44:34.434" v="73" actId="478"/>
+          <ac:picMkLst>
+            <pc:docMk/>
+            <pc:sldMk cId="1753150815" sldId="269"/>
+            <ac:picMk id="17" creationId="{6F599546-9756-000B-F34C-06E469F479E8}"/>
+          </ac:picMkLst>
+        </pc:picChg>
+        <pc:picChg chg="add mod">
+          <ac:chgData name="LOGESH S" userId="536108a5c8606ce5" providerId="LiveId" clId="{BDE1E0A8-B346-494B-B5C1-64FF4A45B7D3}" dt="2026-08-16T09:49:59.979" v="141" actId="14100"/>
+          <ac:picMkLst>
+            <pc:docMk/>
+            <pc:sldMk cId="1753150815" sldId="269"/>
+            <ac:picMk id="19" creationId="{4C6C3DB8-037F-FD76-DE94-E37EE7EE395E}"/>
+          </ac:picMkLst>
+        </pc:picChg>
+        <pc:picChg chg="add mod">
+          <ac:chgData name="LOGESH S" userId="536108a5c8606ce5" providerId="LiveId" clId="{BDE1E0A8-B346-494B-B5C1-64FF4A45B7D3}" dt="2026-08-16T09:49:52.104" v="138" actId="14100"/>
+          <ac:picMkLst>
+            <pc:docMk/>
+            <pc:sldMk cId="1753150815" sldId="269"/>
+            <ac:picMk id="21" creationId="{AF6215F4-0A16-9DEC-8647-EEE9C25B8F28}"/>
+          </ac:picMkLst>
+        </pc:picChg>
+        <pc:picChg chg="add del mod">
+          <ac:chgData name="LOGESH S" userId="536108a5c8606ce5" providerId="LiveId" clId="{BDE1E0A8-B346-494B-B5C1-64FF4A45B7D3}" dt="2026-08-16T09:45:48.559" v="84" actId="478"/>
+          <ac:picMkLst>
+            <pc:docMk/>
+            <pc:sldMk cId="1753150815" sldId="269"/>
+            <ac:picMk id="23" creationId="{175D0F56-6C95-ADEB-4C74-F95119677193}"/>
+          </ac:picMkLst>
+        </pc:picChg>
+        <pc:picChg chg="add del mod">
+          <ac:chgData name="LOGESH S" userId="536108a5c8606ce5" providerId="LiveId" clId="{BDE1E0A8-B346-494B-B5C1-64FF4A45B7D3}" dt="2026-08-16T09:45:48.559" v="84" actId="478"/>
+          <ac:picMkLst>
+            <pc:docMk/>
+            <pc:sldMk cId="1753150815" sldId="269"/>
+            <ac:picMk id="25" creationId="{C5624862-247D-C1C3-38B6-6151EE41B4E0}"/>
+          </ac:picMkLst>
+        </pc:picChg>
+        <pc:picChg chg="add del mod">
+          <ac:chgData name="LOGESH S" userId="536108a5c8606ce5" providerId="LiveId" clId="{BDE1E0A8-B346-494B-B5C1-64FF4A45B7D3}" dt="2026-08-16T09:45:48.559" v="84" actId="478"/>
+          <ac:picMkLst>
+            <pc:docMk/>
+            <pc:sldMk cId="1753150815" sldId="269"/>
+            <ac:picMk id="27" creationId="{B4016E23-29E2-68B7-AD66-8BE6769D86D0}"/>
+          </ac:picMkLst>
+        </pc:picChg>
+        <pc:picChg chg="add mod">
+          <ac:chgData name="LOGESH S" userId="536108a5c8606ce5" providerId="LiveId" clId="{BDE1E0A8-B346-494B-B5C1-64FF4A45B7D3}" dt="2026-08-16T09:50:42.325" v="151" actId="14100"/>
+          <ac:picMkLst>
+            <pc:docMk/>
+            <pc:sldMk cId="1753150815" sldId="269"/>
+            <ac:picMk id="29" creationId="{617AD9EA-908F-347B-C397-870052378709}"/>
+          </ac:picMkLst>
+        </pc:picChg>
+        <pc:picChg chg="add mod">
+          <ac:chgData name="LOGESH S" userId="536108a5c8606ce5" providerId="LiveId" clId="{BDE1E0A8-B346-494B-B5C1-64FF4A45B7D3}" dt="2026-08-16T09:50:21.341" v="146" actId="14100"/>
+          <ac:picMkLst>
+            <pc:docMk/>
+            <pc:sldMk cId="1753150815" sldId="269"/>
+            <ac:picMk id="31" creationId="{35BBAA58-1352-DDAD-169A-8D70BA153ADC}"/>
+          </ac:picMkLst>
+        </pc:picChg>
+        <pc:picChg chg="add mod">
+          <ac:chgData name="LOGESH S" userId="536108a5c8606ce5" providerId="LiveId" clId="{BDE1E0A8-B346-494B-B5C1-64FF4A45B7D3}" dt="2026-08-16T09:50:25.793" v="147" actId="1076"/>
+          <ac:picMkLst>
+            <pc:docMk/>
+            <pc:sldMk cId="1753150815" sldId="269"/>
+            <ac:picMk id="33" creationId="{08F55D04-714A-6984-18B5-E061E7C08172}"/>
+          </ac:picMkLst>
+        </pc:picChg>
+        <pc:picChg chg="add mod">
+          <ac:chgData name="LOGESH S" userId="536108a5c8606ce5" providerId="LiveId" clId="{BDE1E0A8-B346-494B-B5C1-64FF4A45B7D3}" dt="2026-08-16T09:50:34.052" v="149" actId="14100"/>
+          <ac:picMkLst>
+            <pc:docMk/>
+            <pc:sldMk cId="1753150815" sldId="269"/>
+            <ac:picMk id="35" creationId="{A1944E92-A33C-FAB0-5E35-1A0B937BF21A}"/>
+          </ac:picMkLst>
+        </pc:picChg>
+      </pc:sldChg>
+      <pc:sldChg chg="new del">
+        <pc:chgData name="LOGESH S" userId="536108a5c8606ce5" providerId="LiveId" clId="{BDE1E0A8-B346-494B-B5C1-64FF4A45B7D3}" dt="2026-08-16T09:44:01.482" v="70" actId="2696"/>
+        <pc:sldMkLst>
+          <pc:docMk/>
+          <pc:sldMk cId="4075011105" sldId="269"/>
+        </pc:sldMkLst>
+      </pc:sldChg>
+    </pc:docChg>
+  </pc:docChgLst>
+</pc:chgInfo>
 </file>
 
 <file path=ppt/notesMasters/notesMaster1.xml><?xml version="1.0" encoding="utf-8"?>
@@ -574,7 +873,7 @@
           <a:p>
             <a:fld id="{F7021451-1387-4CA6-816F-3879F97B5CBC}" type="slidenum">
               <a:rPr lang="en-US"/>
-              <a:t>13</a:t>
+              <a:t>14</a:t>
             </a:fld>
             <a:endParaRPr lang="en-US"/>
           </a:p>
@@ -1777,7 +2076,7 @@
         <p:spPr>
           <a:xfrm>
             <a:off x="654882" y="2194560"/>
-            <a:ext cx="8595360" cy="822960"/>
+            <a:ext cx="8787698" cy="982980"/>
           </a:xfrm>
           <a:prstGeom prst="rect">
             <a:avLst/>
@@ -1809,11 +2108,10 @@
             <a:endParaRPr lang="en-US" sz="1900" dirty="0"/>
           </a:p>
           <a:p>
-            <a:pPr marL="0" indent="0">
+            <a:pPr>
               <a:lnSpc>
                 <a:spcPts val="2600"/>
               </a:lnSpc>
-              <a:buNone/>
             </a:pPr>
             <a:r>
               <a:rPr lang="en-US" sz="1900" dirty="0">
@@ -1881,7 +2179,7 @@
         <p:spPr>
           <a:xfrm>
             <a:off x="777240" y="4332390"/>
-            <a:ext cx="8531352" cy="1901299"/>
+            <a:ext cx="8531352" cy="2348328"/>
           </a:xfrm>
           <a:prstGeom prst="roundRect">
             <a:avLst>
@@ -2278,6 +2576,90 @@
           </a:prstGeom>
         </p:spPr>
       </p:pic>
+      <p:sp>
+        <p:nvSpPr>
+          <p:cNvPr id="20" name="Text 13">
+            <a:extLst>
+              <a:ext uri="{FF2B5EF4-FFF2-40B4-BE49-F238E27FC236}">
+                <a16:creationId xmlns:a16="http://schemas.microsoft.com/office/drawing/2014/main" id="{7B4C68CF-6CF6-E2E9-E1DB-C76C236AC2BB}"/>
+              </a:ext>
+            </a:extLst>
+          </p:cNvPr>
+          <p:cNvSpPr/>
+          <p:nvPr/>
+        </p:nvSpPr>
+        <p:spPr>
+          <a:xfrm>
+            <a:off x="1072961" y="6086482"/>
+            <a:ext cx="1554480" cy="292608"/>
+          </a:xfrm>
+          <a:prstGeom prst="rect">
+            <a:avLst/>
+          </a:prstGeom>
+          <a:noFill/>
+          <a:ln/>
+        </p:spPr>
+        <p:txBody>
+          <a:bodyPr wrap="square" rtlCol="0" anchor="ctr"/>
+          <a:lstStyle/>
+          <a:p>
+            <a:pPr marL="0" indent="0">
+              <a:buNone/>
+            </a:pPr>
+            <a:r>
+              <a:rPr lang="en-US" sz="1600" b="1" kern="0" spc="100" dirty="0">
+                <a:solidFill>
+                  <a:srgbClr val="00C2D1"/>
+                </a:solidFill>
+                <a:latin typeface="Calibri" pitchFamily="34" charset="0"/>
+                <a:ea typeface="Calibri" pitchFamily="34" charset="-122"/>
+                <a:cs typeface="Calibri" pitchFamily="34" charset="-120"/>
+              </a:rPr>
+              <a:t>URL</a:t>
+            </a:r>
+            <a:endParaRPr lang="en-US" sz="1600" dirty="0"/>
+          </a:p>
+        </p:txBody>
+      </p:sp>
+      <p:sp>
+        <p:nvSpPr>
+          <p:cNvPr id="21" name="TextBox 20">
+            <a:extLst>
+              <a:ext uri="{FF2B5EF4-FFF2-40B4-BE49-F238E27FC236}">
+                <a16:creationId xmlns:a16="http://schemas.microsoft.com/office/drawing/2014/main" id="{CF94BF33-396D-AA49-6010-D07441CEE11D}"/>
+              </a:ext>
+            </a:extLst>
+          </p:cNvPr>
+          <p:cNvSpPr txBox="1"/>
+          <p:nvPr/>
+        </p:nvSpPr>
+        <p:spPr>
+          <a:xfrm>
+            <a:off x="2742576" y="6086482"/>
+            <a:ext cx="3994749" cy="369332"/>
+          </a:xfrm>
+          <a:prstGeom prst="rect">
+            <a:avLst/>
+          </a:prstGeom>
+          <a:noFill/>
+        </p:spPr>
+        <p:txBody>
+          <a:bodyPr wrap="square" rtlCol="0">
+            <a:spAutoFit/>
+          </a:bodyPr>
+          <a:lstStyle/>
+          <a:p>
+            <a:r>
+              <a:rPr lang="en-IN" dirty="0">
+                <a:solidFill>
+                  <a:schemeClr val="bg1"/>
+                </a:solidFill>
+              </a:rPr>
+              <a:t>https://logeshsk-ind.github.io/SIV_AI/</a:t>
+            </a:r>
+          </a:p>
+        </p:txBody>
+      </p:sp>
     </p:spTree>
   </p:cSld>
   <p:clrMapOvr>
@@ -6850,6 +7232,552 @@
 
 <file path=ppt/slides/slide13.xml><?xml version="1.0" encoding="utf-8"?>
 <p:sld xmlns:a="http://schemas.openxmlformats.org/drawingml/2006/main" xmlns:r="http://schemas.openxmlformats.org/officeDocument/2006/relationships" xmlns:p="http://schemas.openxmlformats.org/presentationml/2006/main">
+  <p:cSld>
+    <p:spTree>
+      <p:nvGrpSpPr>
+        <p:cNvPr id="1" name=""/>
+        <p:cNvGrpSpPr/>
+        <p:nvPr/>
+      </p:nvGrpSpPr>
+      <p:grpSpPr>
+        <a:xfrm>
+          <a:off x="0" y="0"/>
+          <a:ext cx="0" cy="0"/>
+          <a:chOff x="0" y="0"/>
+          <a:chExt cx="0" cy="0"/>
+        </a:xfrm>
+      </p:grpSpPr>
+      <p:pic>
+        <p:nvPicPr>
+          <p:cNvPr id="19" name="Picture 18">
+            <a:extLst>
+              <a:ext uri="{FF2B5EF4-FFF2-40B4-BE49-F238E27FC236}">
+                <a16:creationId xmlns:a16="http://schemas.microsoft.com/office/drawing/2014/main" id="{4C6C3DB8-037F-FD76-DE94-E37EE7EE395E}"/>
+              </a:ext>
+            </a:extLst>
+          </p:cNvPr>
+          <p:cNvPicPr>
+            <a:picLocks noChangeAspect="1"/>
+          </p:cNvPicPr>
+          <p:nvPr/>
+        </p:nvPicPr>
+        <p:blipFill>
+          <a:blip r:embed="rId2"/>
+          <a:stretch>
+            <a:fillRect/>
+          </a:stretch>
+        </p:blipFill>
+        <p:spPr>
+          <a:xfrm>
+            <a:off x="1632856" y="-97905"/>
+            <a:ext cx="5048773" cy="2607323"/>
+          </a:xfrm>
+          <a:prstGeom prst="rect">
+            <a:avLst/>
+          </a:prstGeom>
+        </p:spPr>
+      </p:pic>
+      <p:pic>
+        <p:nvPicPr>
+          <p:cNvPr id="21" name="Picture 20">
+            <a:extLst>
+              <a:ext uri="{FF2B5EF4-FFF2-40B4-BE49-F238E27FC236}">
+                <a16:creationId xmlns:a16="http://schemas.microsoft.com/office/drawing/2014/main" id="{AF6215F4-0A16-9DEC-8647-EEE9C25B8F28}"/>
+              </a:ext>
+            </a:extLst>
+          </p:cNvPr>
+          <p:cNvPicPr>
+            <a:picLocks noChangeAspect="1"/>
+          </p:cNvPicPr>
+          <p:nvPr/>
+        </p:nvPicPr>
+        <p:blipFill>
+          <a:blip r:embed="rId3"/>
+          <a:stretch>
+            <a:fillRect/>
+          </a:stretch>
+        </p:blipFill>
+        <p:spPr>
+          <a:xfrm>
+            <a:off x="6702423" y="-97906"/>
+            <a:ext cx="5486401" cy="2607323"/>
+          </a:xfrm>
+          <a:prstGeom prst="rect">
+            <a:avLst/>
+          </a:prstGeom>
+        </p:spPr>
+      </p:pic>
+      <p:pic>
+        <p:nvPicPr>
+          <p:cNvPr id="29" name="Picture 28">
+            <a:extLst>
+              <a:ext uri="{FF2B5EF4-FFF2-40B4-BE49-F238E27FC236}">
+                <a16:creationId xmlns:a16="http://schemas.microsoft.com/office/drawing/2014/main" id="{617AD9EA-908F-347B-C397-870052378709}"/>
+              </a:ext>
+            </a:extLst>
+          </p:cNvPr>
+          <p:cNvPicPr>
+            <a:picLocks noChangeAspect="1"/>
+          </p:cNvPicPr>
+          <p:nvPr/>
+        </p:nvPicPr>
+        <p:blipFill>
+          <a:blip r:embed="rId4"/>
+          <a:stretch>
+            <a:fillRect/>
+          </a:stretch>
+        </p:blipFill>
+        <p:spPr>
+          <a:xfrm>
+            <a:off x="0" y="2482088"/>
+            <a:ext cx="6410129" cy="2532970"/>
+          </a:xfrm>
+          <a:prstGeom prst="rect">
+            <a:avLst/>
+          </a:prstGeom>
+        </p:spPr>
+      </p:pic>
+      <p:pic>
+        <p:nvPicPr>
+          <p:cNvPr id="31" name="Picture 30">
+            <a:extLst>
+              <a:ext uri="{FF2B5EF4-FFF2-40B4-BE49-F238E27FC236}">
+                <a16:creationId xmlns:a16="http://schemas.microsoft.com/office/drawing/2014/main" id="{35BBAA58-1352-DDAD-169A-8D70BA153ADC}"/>
+              </a:ext>
+            </a:extLst>
+          </p:cNvPr>
+          <p:cNvPicPr>
+            <a:picLocks noChangeAspect="1"/>
+          </p:cNvPicPr>
+          <p:nvPr/>
+        </p:nvPicPr>
+        <p:blipFill>
+          <a:blip r:embed="rId5"/>
+          <a:stretch>
+            <a:fillRect/>
+          </a:stretch>
+        </p:blipFill>
+        <p:spPr>
+          <a:xfrm>
+            <a:off x="6400799" y="2499861"/>
+            <a:ext cx="6058612" cy="2389220"/>
+          </a:xfrm>
+          <a:prstGeom prst="rect">
+            <a:avLst/>
+          </a:prstGeom>
+        </p:spPr>
+      </p:pic>
+      <p:pic>
+        <p:nvPicPr>
+          <p:cNvPr id="33" name="Picture 32">
+            <a:extLst>
+              <a:ext uri="{FF2B5EF4-FFF2-40B4-BE49-F238E27FC236}">
+                <a16:creationId xmlns:a16="http://schemas.microsoft.com/office/drawing/2014/main" id="{08F55D04-714A-6984-18B5-E061E7C08172}"/>
+              </a:ext>
+            </a:extLst>
+          </p:cNvPr>
+          <p:cNvPicPr>
+            <a:picLocks noChangeAspect="1"/>
+          </p:cNvPicPr>
+          <p:nvPr/>
+        </p:nvPicPr>
+        <p:blipFill>
+          <a:blip r:embed="rId6"/>
+          <a:stretch>
+            <a:fillRect/>
+          </a:stretch>
+        </p:blipFill>
+        <p:spPr>
+          <a:xfrm>
+            <a:off x="6094412" y="4701721"/>
+            <a:ext cx="5596526" cy="2393237"/>
+          </a:xfrm>
+          <a:prstGeom prst="rect">
+            <a:avLst/>
+          </a:prstGeom>
+        </p:spPr>
+      </p:pic>
+      <p:pic>
+        <p:nvPicPr>
+          <p:cNvPr id="35" name="Picture 34">
+            <a:extLst>
+              <a:ext uri="{FF2B5EF4-FFF2-40B4-BE49-F238E27FC236}">
+                <a16:creationId xmlns:a16="http://schemas.microsoft.com/office/drawing/2014/main" id="{A1944E92-A33C-FAB0-5E35-1A0B937BF21A}"/>
+              </a:ext>
+            </a:extLst>
+          </p:cNvPr>
+          <p:cNvPicPr>
+            <a:picLocks noChangeAspect="1"/>
+          </p:cNvPicPr>
+          <p:nvPr/>
+        </p:nvPicPr>
+        <p:blipFill>
+          <a:blip r:embed="rId7"/>
+          <a:stretch>
+            <a:fillRect/>
+          </a:stretch>
+        </p:blipFill>
+        <p:spPr>
+          <a:xfrm>
+            <a:off x="-17040" y="4735352"/>
+            <a:ext cx="6111452" cy="2217347"/>
+          </a:xfrm>
+          <a:prstGeom prst="rect">
+            <a:avLst/>
+          </a:prstGeom>
+        </p:spPr>
+      </p:pic>
+      <p:sp>
+        <p:nvSpPr>
+          <p:cNvPr id="36" name="Oval 35">
+            <a:extLst>
+              <a:ext uri="{FF2B5EF4-FFF2-40B4-BE49-F238E27FC236}">
+                <a16:creationId xmlns:a16="http://schemas.microsoft.com/office/drawing/2014/main" id="{E244C643-6FF7-0C5E-62CF-45E93C464D5E}"/>
+              </a:ext>
+            </a:extLst>
+          </p:cNvPr>
+          <p:cNvSpPr/>
+          <p:nvPr/>
+        </p:nvSpPr>
+        <p:spPr>
+          <a:xfrm>
+            <a:off x="1689040" y="63013"/>
+            <a:ext cx="447869" cy="393835"/>
+          </a:xfrm>
+          <a:prstGeom prst="ellipse">
+            <a:avLst/>
+          </a:prstGeom>
+        </p:spPr>
+        <p:style>
+          <a:lnRef idx="2">
+            <a:schemeClr val="accent1">
+              <a:shade val="15000"/>
+            </a:schemeClr>
+          </a:lnRef>
+          <a:fillRef idx="1">
+            <a:schemeClr val="accent1"/>
+          </a:fillRef>
+          <a:effectRef idx="0">
+            <a:schemeClr val="accent1"/>
+          </a:effectRef>
+          <a:fontRef idx="minor">
+            <a:schemeClr val="lt1"/>
+          </a:fontRef>
+        </p:style>
+        <p:txBody>
+          <a:bodyPr rtlCol="0" anchor="ctr"/>
+          <a:lstStyle/>
+          <a:p>
+            <a:pPr algn="ctr"/>
+            <a:r>
+              <a:rPr lang="en-IN" dirty="0"/>
+              <a:t>1</a:t>
+            </a:r>
+          </a:p>
+        </p:txBody>
+      </p:sp>
+      <p:sp>
+        <p:nvSpPr>
+          <p:cNvPr id="38" name="Oval 37">
+            <a:extLst>
+              <a:ext uri="{FF2B5EF4-FFF2-40B4-BE49-F238E27FC236}">
+                <a16:creationId xmlns:a16="http://schemas.microsoft.com/office/drawing/2014/main" id="{1BBA7258-D560-77CF-A4EB-13F794E33A56}"/>
+              </a:ext>
+            </a:extLst>
+          </p:cNvPr>
+          <p:cNvSpPr/>
+          <p:nvPr/>
+        </p:nvSpPr>
+        <p:spPr>
+          <a:xfrm>
+            <a:off x="6826965" y="205272"/>
+            <a:ext cx="447869" cy="393835"/>
+          </a:xfrm>
+          <a:prstGeom prst="ellipse">
+            <a:avLst/>
+          </a:prstGeom>
+        </p:spPr>
+        <p:style>
+          <a:lnRef idx="2">
+            <a:schemeClr val="accent1">
+              <a:shade val="15000"/>
+            </a:schemeClr>
+          </a:lnRef>
+          <a:fillRef idx="1">
+            <a:schemeClr val="accent1"/>
+          </a:fillRef>
+          <a:effectRef idx="0">
+            <a:schemeClr val="accent1"/>
+          </a:effectRef>
+          <a:fontRef idx="minor">
+            <a:schemeClr val="lt1"/>
+          </a:fontRef>
+        </p:style>
+        <p:txBody>
+          <a:bodyPr rtlCol="0" anchor="ctr"/>
+          <a:lstStyle/>
+          <a:p>
+            <a:pPr algn="ctr"/>
+            <a:r>
+              <a:rPr lang="en-IN" dirty="0"/>
+              <a:t>2</a:t>
+            </a:r>
+          </a:p>
+        </p:txBody>
+      </p:sp>
+      <p:sp>
+        <p:nvSpPr>
+          <p:cNvPr id="40" name="Oval 39">
+            <a:extLst>
+              <a:ext uri="{FF2B5EF4-FFF2-40B4-BE49-F238E27FC236}">
+                <a16:creationId xmlns:a16="http://schemas.microsoft.com/office/drawing/2014/main" id="{EE2C66D2-FFEF-0FBE-DE1A-638156011E25}"/>
+              </a:ext>
+            </a:extLst>
+          </p:cNvPr>
+          <p:cNvSpPr/>
+          <p:nvPr/>
+        </p:nvSpPr>
+        <p:spPr>
+          <a:xfrm>
+            <a:off x="121298" y="2780336"/>
+            <a:ext cx="447869" cy="393835"/>
+          </a:xfrm>
+          <a:prstGeom prst="ellipse">
+            <a:avLst/>
+          </a:prstGeom>
+        </p:spPr>
+        <p:style>
+          <a:lnRef idx="2">
+            <a:schemeClr val="accent1">
+              <a:shade val="15000"/>
+            </a:schemeClr>
+          </a:lnRef>
+          <a:fillRef idx="1">
+            <a:schemeClr val="accent1"/>
+          </a:fillRef>
+          <a:effectRef idx="0">
+            <a:schemeClr val="accent1"/>
+          </a:effectRef>
+          <a:fontRef idx="minor">
+            <a:schemeClr val="lt1"/>
+          </a:fontRef>
+        </p:style>
+        <p:txBody>
+          <a:bodyPr rtlCol="0" anchor="ctr"/>
+          <a:lstStyle/>
+          <a:p>
+            <a:pPr algn="ctr"/>
+            <a:r>
+              <a:rPr lang="en-IN" dirty="0"/>
+              <a:t>3</a:t>
+            </a:r>
+          </a:p>
+        </p:txBody>
+      </p:sp>
+      <p:sp>
+        <p:nvSpPr>
+          <p:cNvPr id="42" name="Oval 41">
+            <a:extLst>
+              <a:ext uri="{FF2B5EF4-FFF2-40B4-BE49-F238E27FC236}">
+                <a16:creationId xmlns:a16="http://schemas.microsoft.com/office/drawing/2014/main" id="{465CF17B-5C70-712D-2318-6A52535928B3}"/>
+              </a:ext>
+            </a:extLst>
+          </p:cNvPr>
+          <p:cNvSpPr/>
+          <p:nvPr/>
+        </p:nvSpPr>
+        <p:spPr>
+          <a:xfrm>
+            <a:off x="6457694" y="2780336"/>
+            <a:ext cx="447869" cy="393835"/>
+          </a:xfrm>
+          <a:prstGeom prst="ellipse">
+            <a:avLst/>
+          </a:prstGeom>
+        </p:spPr>
+        <p:style>
+          <a:lnRef idx="2">
+            <a:schemeClr val="accent1">
+              <a:shade val="15000"/>
+            </a:schemeClr>
+          </a:lnRef>
+          <a:fillRef idx="1">
+            <a:schemeClr val="accent1"/>
+          </a:fillRef>
+          <a:effectRef idx="0">
+            <a:schemeClr val="accent1"/>
+          </a:effectRef>
+          <a:fontRef idx="minor">
+            <a:schemeClr val="lt1"/>
+          </a:fontRef>
+        </p:style>
+        <p:txBody>
+          <a:bodyPr rtlCol="0" anchor="ctr"/>
+          <a:lstStyle/>
+          <a:p>
+            <a:pPr algn="ctr"/>
+            <a:r>
+              <a:rPr lang="en-IN" dirty="0"/>
+              <a:t>4</a:t>
+            </a:r>
+          </a:p>
+        </p:txBody>
+      </p:sp>
+      <p:sp>
+        <p:nvSpPr>
+          <p:cNvPr id="44" name="Oval 43">
+            <a:extLst>
+              <a:ext uri="{FF2B5EF4-FFF2-40B4-BE49-F238E27FC236}">
+                <a16:creationId xmlns:a16="http://schemas.microsoft.com/office/drawing/2014/main" id="{E95881CD-6BB4-2AEE-C1B7-B2911CB7E23D}"/>
+              </a:ext>
+            </a:extLst>
+          </p:cNvPr>
+          <p:cNvSpPr/>
+          <p:nvPr/>
+        </p:nvSpPr>
+        <p:spPr>
+          <a:xfrm>
+            <a:off x="-27992" y="4818141"/>
+            <a:ext cx="447869" cy="393835"/>
+          </a:xfrm>
+          <a:prstGeom prst="ellipse">
+            <a:avLst/>
+          </a:prstGeom>
+        </p:spPr>
+        <p:style>
+          <a:lnRef idx="2">
+            <a:schemeClr val="accent1">
+              <a:shade val="15000"/>
+            </a:schemeClr>
+          </a:lnRef>
+          <a:fillRef idx="1">
+            <a:schemeClr val="accent1"/>
+          </a:fillRef>
+          <a:effectRef idx="0">
+            <a:schemeClr val="accent1"/>
+          </a:effectRef>
+          <a:fontRef idx="minor">
+            <a:schemeClr val="lt1"/>
+          </a:fontRef>
+        </p:style>
+        <p:txBody>
+          <a:bodyPr rtlCol="0" anchor="ctr"/>
+          <a:lstStyle/>
+          <a:p>
+            <a:pPr algn="ctr"/>
+            <a:r>
+              <a:rPr lang="en-IN" dirty="0"/>
+              <a:t>6</a:t>
+            </a:r>
+          </a:p>
+        </p:txBody>
+      </p:sp>
+      <p:sp>
+        <p:nvSpPr>
+          <p:cNvPr id="46" name="Oval 45">
+            <a:extLst>
+              <a:ext uri="{FF2B5EF4-FFF2-40B4-BE49-F238E27FC236}">
+                <a16:creationId xmlns:a16="http://schemas.microsoft.com/office/drawing/2014/main" id="{C5A47210-C323-82F5-AA7E-8A28FB15728D}"/>
+              </a:ext>
+            </a:extLst>
+          </p:cNvPr>
+          <p:cNvSpPr/>
+          <p:nvPr/>
+        </p:nvSpPr>
+        <p:spPr>
+          <a:xfrm>
+            <a:off x="6094412" y="4507303"/>
+            <a:ext cx="447869" cy="393835"/>
+          </a:xfrm>
+          <a:prstGeom prst="ellipse">
+            <a:avLst/>
+          </a:prstGeom>
+        </p:spPr>
+        <p:style>
+          <a:lnRef idx="2">
+            <a:schemeClr val="accent1">
+              <a:shade val="15000"/>
+            </a:schemeClr>
+          </a:lnRef>
+          <a:fillRef idx="1">
+            <a:schemeClr val="accent1"/>
+          </a:fillRef>
+          <a:effectRef idx="0">
+            <a:schemeClr val="accent1"/>
+          </a:effectRef>
+          <a:fontRef idx="minor">
+            <a:schemeClr val="lt1"/>
+          </a:fontRef>
+        </p:style>
+        <p:txBody>
+          <a:bodyPr rtlCol="0" anchor="ctr"/>
+          <a:lstStyle/>
+          <a:p>
+            <a:pPr algn="ctr"/>
+            <a:r>
+              <a:rPr lang="en-IN" dirty="0"/>
+              <a:t>5</a:t>
+            </a:r>
+          </a:p>
+        </p:txBody>
+      </p:sp>
+      <p:sp>
+        <p:nvSpPr>
+          <p:cNvPr id="47" name="TextBox 46">
+            <a:extLst>
+              <a:ext uri="{FF2B5EF4-FFF2-40B4-BE49-F238E27FC236}">
+                <a16:creationId xmlns:a16="http://schemas.microsoft.com/office/drawing/2014/main" id="{C5631F0B-0319-2B3F-226F-3DA1B4C172FB}"/>
+              </a:ext>
+            </a:extLst>
+          </p:cNvPr>
+          <p:cNvSpPr txBox="1"/>
+          <p:nvPr/>
+        </p:nvSpPr>
+        <p:spPr>
+          <a:xfrm>
+            <a:off x="121298" y="456848"/>
+            <a:ext cx="1166326" cy="954107"/>
+          </a:xfrm>
+          <a:prstGeom prst="rect">
+            <a:avLst/>
+          </a:prstGeom>
+          <a:noFill/>
+        </p:spPr>
+        <p:txBody>
+          <a:bodyPr wrap="square" rtlCol="0">
+            <a:spAutoFit/>
+          </a:bodyPr>
+          <a:lstStyle/>
+          <a:p>
+            <a:r>
+              <a:rPr lang="en-IN" sz="2800" b="1" dirty="0"/>
+              <a:t>WEB</a:t>
+            </a:r>
+            <a:br>
+              <a:rPr lang="en-IN" sz="2800" b="1" dirty="0"/>
+            </a:br>
+            <a:r>
+              <a:rPr lang="en-IN" sz="2800" b="1" dirty="0"/>
+              <a:t>DEMO</a:t>
+            </a:r>
+          </a:p>
+        </p:txBody>
+      </p:sp>
+    </p:spTree>
+    <p:extLst>
+      <p:ext uri="{BB962C8B-B14F-4D97-AF65-F5344CB8AC3E}">
+        <p14:creationId xmlns:p14="http://schemas.microsoft.com/office/powerpoint/2010/main" val="1753150815"/>
+      </p:ext>
+    </p:extLst>
+  </p:cSld>
+  <p:clrMapOvr>
+    <a:masterClrMapping/>
+  </p:clrMapOvr>
+</p:sld>
+</file>
+
+<file path=ppt/slides/slide14.xml><?xml version="1.0" encoding="utf-8"?>
+<p:sld xmlns:a="http://schemas.openxmlformats.org/drawingml/2006/main" xmlns:r="http://schemas.openxmlformats.org/officeDocument/2006/relationships" xmlns:p="http://schemas.openxmlformats.org/presentationml/2006/main">
   <p:cSld name="Slide 12">
     <p:bg>
       <p:bgPr>
@@ -8402,7 +9330,7 @@
         <p:spPr>
           <a:xfrm>
             <a:off x="2103120" y="5897880"/>
-            <a:ext cx="4754880" cy="685800"/>
+            <a:ext cx="2642616" cy="685800"/>
           </a:xfrm>
           <a:prstGeom prst="rect">
             <a:avLst/>
@@ -8465,7 +9393,7 @@
                 <a:ea typeface="Calibri" pitchFamily="34" charset="-122"/>
                 <a:cs typeface="Calibri" pitchFamily="34" charset="-120"/>
               </a:rPr>
-              <a:t>FINAL CHECKPOINT</a:t>
+              <a:t>URL</a:t>
             </a:r>
             <a:endParaRPr lang="en-US" sz="1050" dirty="0"/>
           </a:p>
@@ -8479,22 +9407,19 @@
         </p:nvSpPr>
         <p:spPr>
           <a:xfrm>
-            <a:off x="8869680" y="5897880"/>
-            <a:ext cx="2651760" cy="685800"/>
-          </a:xfrm>
-          <a:prstGeom prst="rect">
-            <a:avLst/>
-          </a:prstGeom>
-          <a:noFill/>
-          <a:ln/>
-        </p:spPr>
-        <p:txBody>
-          <a:bodyPr wrap="square" rtlCol="0" anchor="ctr"/>
-          <a:lstStyle/>
-          <a:p>
-            <a:pPr marL="0" indent="0">
-              <a:buNone/>
-            </a:pPr>
+            <a:off x="8042988" y="5897880"/>
+            <a:ext cx="3478452" cy="685800"/>
+          </a:xfrm>
+          <a:prstGeom prst="rect">
+            <a:avLst/>
+          </a:prstGeom>
+          <a:noFill/>
+          <a:ln/>
+        </p:spPr>
+        <p:txBody>
+          <a:bodyPr wrap="square" rtlCol="0" anchor="ctr"/>
+          <a:lstStyle/>
+          <a:p>
             <a:r>
               <a:rPr lang="en-US" sz="1300" dirty="0">
                 <a:solidFill>
@@ -8504,7 +9429,7 @@
                 <a:ea typeface="Calibri" pitchFamily="34" charset="-122"/>
                 <a:cs typeface="Calibri" pitchFamily="34" charset="-120"/>
               </a:rPr>
-              <a:t>[Checkpoint Name]</a:t>
+              <a:t>https://logeshsk-ind.github.io/SIV_AI/</a:t>
             </a:r>
             <a:endParaRPr lang="en-US" sz="1300" dirty="0"/>
           </a:p>

</xml_diff>